<commit_message>
Retirar logos y nombres institucionales
Se eliminan el logo, los fondos corporativos y las menciones a la
institución aliada y al cliente en la web, las plantillas de acceso,
app.py, los scripts y los documentos de práctica (.docx, .pptx y el kit
.zip). La marca queda como «Misión Copilot 365».

Co-Authored-By: Claude Opus 5.5 <noreply@anthropic.com>
Claude-Session: https://claude.ai/code/session_01R22aXvJDJH6WRoJr3qZz6c
</commit_message>
<xml_diff>
--- a/planillas/07_Plantilla_Comite_Horizonte.pptx
+++ b/planillas/07_Plantilla_Comite_Horizonte.pptx
@@ -3097,7 +3097,7 @@
       <p:grpSpPr/>
       <p:pic>
         <p:nvPicPr>
-          <p:cNvPr id="2" name="Picture 1" descr="FONDO PANTALLA -ECCO (2) (1) (2) (1).png"/>
+          <p:cNvPr id="2" name="Picture 1" descr="Fondo"/>
           <p:cNvPicPr>
             <a:picLocks noChangeAspect="1"/>
           </p:cNvPicPr>
@@ -3247,7 +3247,7 @@
       <p:grpSpPr/>
       <p:pic>
         <p:nvPicPr>
-          <p:cNvPr id="2" name="Picture 1" descr="FONDO PANTALLA -ECCO (2) (1) (2) (1).png"/>
+          <p:cNvPr id="2" name="Picture 1" descr="Fondo"/>
           <p:cNvPicPr>
             <a:picLocks noChangeAspect="1"/>
           </p:cNvPicPr>
@@ -3709,7 +3709,7 @@
       <p:grpSpPr/>
       <p:pic>
         <p:nvPicPr>
-          <p:cNvPr id="2" name="Picture 1" descr="FONDO PANTALLA -ECCO (2) (1) (2) (1).png"/>
+          <p:cNvPr id="2" name="Picture 1" descr="Fondo"/>
           <p:cNvPicPr>
             <a:picLocks noChangeAspect="1"/>
           </p:cNvPicPr>
@@ -4171,7 +4171,7 @@
       <p:grpSpPr/>
       <p:pic>
         <p:nvPicPr>
-          <p:cNvPr id="2" name="Picture 1" descr="FONDO PANTALLA -ECCO (2) (1) (2) (1).png"/>
+          <p:cNvPr id="2" name="Picture 1" descr="Fondo"/>
           <p:cNvPicPr>
             <a:picLocks noChangeAspect="1"/>
           </p:cNvPicPr>
@@ -4633,7 +4633,7 @@
       <p:grpSpPr/>
       <p:pic>
         <p:nvPicPr>
-          <p:cNvPr id="2" name="Picture 1" descr="FONDO PANTALLA -ECCO (2) (1) (2) (1).png"/>
+          <p:cNvPr id="2" name="Picture 1" descr="Fondo"/>
           <p:cNvPicPr>
             <a:picLocks noChangeAspect="1"/>
           </p:cNvPicPr>
@@ -5095,7 +5095,7 @@
       <p:grpSpPr/>
       <p:pic>
         <p:nvPicPr>
-          <p:cNvPr id="2" name="Picture 1" descr="FONDO PANTALLA -ECCO (2) (1) (2) (1).png"/>
+          <p:cNvPr id="2" name="Picture 1" descr="Fondo"/>
           <p:cNvPicPr>
             <a:picLocks noChangeAspect="1"/>
           </p:cNvPicPr>
@@ -5557,7 +5557,7 @@
       <p:grpSpPr/>
       <p:pic>
         <p:nvPicPr>
-          <p:cNvPr id="2" name="Picture 1" descr="FONDO PANTALLA -ECCO (2) (1) (2) (1).png"/>
+          <p:cNvPr id="2" name="Picture 1" descr="Fondo"/>
           <p:cNvPicPr>
             <a:picLocks noChangeAspect="1"/>
           </p:cNvPicPr>
@@ -6019,7 +6019,7 @@
       <p:grpSpPr/>
       <p:pic>
         <p:nvPicPr>
-          <p:cNvPr id="2" name="Picture 1" descr="FONDO PANTALLA -ECCO (2) (1) (2) (1).png"/>
+          <p:cNvPr id="2" name="Picture 1" descr="Fondo"/>
           <p:cNvPicPr>
             <a:picLocks noChangeAspect="1"/>
           </p:cNvPicPr>

</xml_diff>